<commit_message>
update semenar and report generate Arabic language
</commit_message>
<xml_diff>
--- a/scratch/test_presentation.pptx
+++ b/scratch/test_presentation.pptx
@@ -5085,6 +5085,23 @@
               <a:t>• سەرچاوە: Goodfellow, I. (2023). Deep Learning. MIT Press.</a:t>
             </a:r>
           </a:p>
+          <a:p>
+            <a:pPr algn="ctr" rtl="1">
+              <a:spcBef>
+                <a:spcPts val="1200"/>
+              </a:spcBef>
+            </a:pPr>
+            <a:r>
+              <a:rPr lang="ar-IQ" sz="2000" b="1">
+                <a:solidFill>
+                  <a:srgbClr val="2563EB"/>
+                </a:solidFill>
+                <a:latin typeface="Calibri"/>
+                <a:cs typeface="Calibri"/>
+              </a:rPr>
+              <a:t>✨ سوپاس بۆ ئامادەبوونتان ✨</a:t>
+            </a:r>
+          </a:p>
         </p:txBody>
       </p:sp>
       <p:sp>

</xml_diff>